<commit_message>
Session 3 Aug 8
</commit_message>
<xml_diff>
--- a/session3/Choosing Between Models.pptx
+++ b/session3/Choosing Between Models.pptx
@@ -116,6 +116,11 @@
       </a:defRPr>
     </a:lvl9pPr>
   </p:defaultTextStyle>
+  <p:extLst>
+    <p:ext uri="{EFAFB233-063F-42B5-8137-9DF3F51BA10A}">
+      <p15:sldGuideLst xmlns:p15="http://schemas.microsoft.com/office/powerpoint/2012/main"/>
+    </p:ext>
+  </p:extLst>
 </p:presentation>
 </file>
 
@@ -345,7 +350,7 @@
           <a:p>
             <a:fld id="{F62967BC-126F-4822-9086-14CEAD50BE3A}" type="datetimeFigureOut">
               <a:rPr lang="en-IN" smtClean="0"/>
-              <a:t>07-08-2026</a:t>
+              <a:t>08-08-2026</a:t>
             </a:fld>
             <a:endParaRPr lang="en-IN"/>
           </a:p>
@@ -553,7 +558,7 @@
           <a:p>
             <a:fld id="{F62967BC-126F-4822-9086-14CEAD50BE3A}" type="datetimeFigureOut">
               <a:rPr lang="en-IN" smtClean="0"/>
-              <a:t>07-08-2026</a:t>
+              <a:t>08-08-2026</a:t>
             </a:fld>
             <a:endParaRPr lang="en-IN"/>
           </a:p>
@@ -809,7 +814,7 @@
           <a:p>
             <a:fld id="{F62967BC-126F-4822-9086-14CEAD50BE3A}" type="datetimeFigureOut">
               <a:rPr lang="en-IN" smtClean="0"/>
-              <a:t>07-08-2026</a:t>
+              <a:t>08-08-2026</a:t>
             </a:fld>
             <a:endParaRPr lang="en-IN"/>
           </a:p>
@@ -983,7 +988,7 @@
           <a:p>
             <a:fld id="{F62967BC-126F-4822-9086-14CEAD50BE3A}" type="datetimeFigureOut">
               <a:rPr lang="en-IN" smtClean="0"/>
-              <a:t>07-08-2026</a:t>
+              <a:t>08-08-2026</a:t>
             </a:fld>
             <a:endParaRPr lang="en-IN"/>
           </a:p>
@@ -1326,7 +1331,7 @@
           <a:p>
             <a:fld id="{F62967BC-126F-4822-9086-14CEAD50BE3A}" type="datetimeFigureOut">
               <a:rPr lang="en-IN" smtClean="0"/>
-              <a:t>07-08-2026</a:t>
+              <a:t>08-08-2026</a:t>
             </a:fld>
             <a:endParaRPr lang="en-IN"/>
           </a:p>
@@ -1601,7 +1606,7 @@
           <a:p>
             <a:fld id="{F62967BC-126F-4822-9086-14CEAD50BE3A}" type="datetimeFigureOut">
               <a:rPr lang="en-IN" smtClean="0"/>
-              <a:t>07-08-2026</a:t>
+              <a:t>08-08-2026</a:t>
             </a:fld>
             <a:endParaRPr lang="en-IN"/>
           </a:p>
@@ -1980,7 +1985,7 @@
           <a:p>
             <a:fld id="{F62967BC-126F-4822-9086-14CEAD50BE3A}" type="datetimeFigureOut">
               <a:rPr lang="en-IN" smtClean="0"/>
-              <a:t>07-08-2026</a:t>
+              <a:t>08-08-2026</a:t>
             </a:fld>
             <a:endParaRPr lang="en-IN"/>
           </a:p>
@@ -2098,7 +2103,7 @@
           <a:p>
             <a:fld id="{F62967BC-126F-4822-9086-14CEAD50BE3A}" type="datetimeFigureOut">
               <a:rPr lang="en-IN" smtClean="0"/>
-              <a:t>07-08-2026</a:t>
+              <a:t>08-08-2026</a:t>
             </a:fld>
             <a:endParaRPr lang="en-IN"/>
           </a:p>
@@ -2269,7 +2274,7 @@
           <a:p>
             <a:fld id="{F62967BC-126F-4822-9086-14CEAD50BE3A}" type="datetimeFigureOut">
               <a:rPr lang="en-IN" smtClean="0"/>
-              <a:t>07-08-2026</a:t>
+              <a:t>08-08-2026</a:t>
             </a:fld>
             <a:endParaRPr lang="en-IN"/>
           </a:p>
@@ -2623,7 +2628,7 @@
           <a:p>
             <a:fld id="{F62967BC-126F-4822-9086-14CEAD50BE3A}" type="datetimeFigureOut">
               <a:rPr lang="en-IN" smtClean="0"/>
-              <a:t>07-08-2026</a:t>
+              <a:t>08-08-2026</a:t>
             </a:fld>
             <a:endParaRPr lang="en-IN"/>
           </a:p>
@@ -3005,7 +3010,7 @@
           <a:p>
             <a:fld id="{F62967BC-126F-4822-9086-14CEAD50BE3A}" type="datetimeFigureOut">
               <a:rPr lang="en-IN" smtClean="0"/>
-              <a:t>07-08-2026</a:t>
+              <a:t>08-08-2026</a:t>
             </a:fld>
             <a:endParaRPr lang="en-IN"/>
           </a:p>
@@ -3292,7 +3297,7 @@
           <a:p>
             <a:fld id="{F62967BC-126F-4822-9086-14CEAD50BE3A}" type="datetimeFigureOut">
               <a:rPr lang="en-IN" smtClean="0"/>
-              <a:t>07-08-2026</a:t>
+              <a:t>08-08-2026</a:t>
             </a:fld>
             <a:endParaRPr lang="en-IN"/>
           </a:p>
@@ -3978,6 +3983,46 @@
           </a:p>
         </p:txBody>
       </p:sp>
+      <p:sp>
+        <p:nvSpPr>
+          <p:cNvPr id="4" name="Right Arrow 3"/>
+          <p:cNvSpPr/>
+          <p:nvPr/>
+        </p:nvSpPr>
+        <p:spPr>
+          <a:xfrm>
+            <a:off x="222190" y="1204958"/>
+            <a:ext cx="649481" cy="470566"/>
+          </a:xfrm>
+          <a:prstGeom prst="rightArrow">
+            <a:avLst/>
+          </a:prstGeom>
+        </p:spPr>
+        <p:style>
+          <a:lnRef idx="2">
+            <a:schemeClr val="accent1">
+              <a:shade val="50000"/>
+            </a:schemeClr>
+          </a:lnRef>
+          <a:fillRef idx="1">
+            <a:schemeClr val="accent1"/>
+          </a:fillRef>
+          <a:effectRef idx="0">
+            <a:schemeClr val="accent1"/>
+          </a:effectRef>
+          <a:fontRef idx="minor">
+            <a:schemeClr val="lt1"/>
+          </a:fontRef>
+        </p:style>
+        <p:txBody>
+          <a:bodyPr rtlCol="0" anchor="ctr"/>
+          <a:lstStyle/>
+          <a:p>
+            <a:pPr algn="ctr"/>
+            <a:endParaRPr lang="en-IN"/>
+          </a:p>
+        </p:txBody>
+      </p:sp>
     </p:spTree>
     <p:extLst>
       <p:ext uri="{BB962C8B-B14F-4D97-AF65-F5344CB8AC3E}">
@@ -4055,7 +4100,7 @@
         </p:nvSpPr>
         <p:spPr>
           <a:xfrm>
-            <a:off x="838200" y="1059679"/>
+            <a:off x="838200" y="1504060"/>
             <a:ext cx="10515600" cy="5117284"/>
           </a:xfrm>
         </p:spPr>
@@ -4089,7 +4134,7 @@
           </a:p>
           <a:p>
             <a:r>
-              <a:rPr lang="en-US" sz="1600" dirty="0"/>
+              <a:rPr lang="en-US" sz="1600" b="1" dirty="0"/>
               <a:t>Reasoning Model will work like below</a:t>
             </a:r>
           </a:p>
@@ -4107,32 +4152,52 @@
           </a:p>
           <a:p>
             <a:r>
+              <a:rPr lang="en-US" sz="1600" dirty="0" smtClean="0"/>
+              <a:t>1.Fetch </a:t>
+            </a:r>
+            <a:r>
               <a:rPr lang="en-US" sz="1600" dirty="0"/>
-              <a:t>Fetch Order details</a:t>
-            </a:r>
-          </a:p>
-          <a:p>
+              <a:t>Order details</a:t>
+            </a:r>
+          </a:p>
+          <a:p>
+            <a:r>
+              <a:rPr lang="en-US" sz="1600" dirty="0" smtClean="0"/>
+              <a:t>2. Fetch </a:t>
+            </a:r>
             <a:r>
               <a:rPr lang="en-US" sz="1600" dirty="0"/>
-              <a:t>Fetch Last 5 month Order details</a:t>
-            </a:r>
-          </a:p>
-          <a:p>
+              <a:t>Last 5 month Order details</a:t>
+            </a:r>
+          </a:p>
+          <a:p>
+            <a:r>
+              <a:rPr lang="en-US" sz="1600" dirty="0" smtClean="0"/>
+              <a:t>3.Combine </a:t>
+            </a:r>
             <a:r>
               <a:rPr lang="en-US" sz="1600" dirty="0"/>
-              <a:t>Combine Both into one.</a:t>
-            </a:r>
-          </a:p>
-          <a:p>
+              <a:t>Both into one.</a:t>
+            </a:r>
+          </a:p>
+          <a:p>
+            <a:r>
+              <a:rPr lang="en-US" sz="1600" dirty="0" smtClean="0"/>
+              <a:t>4. Draft </a:t>
+            </a:r>
             <a:r>
               <a:rPr lang="en-US" sz="1600" dirty="0"/>
-              <a:t>Draft User professional Email</a:t>
-            </a:r>
-          </a:p>
-          <a:p>
+              <a:t>User professional Email</a:t>
+            </a:r>
+          </a:p>
+          <a:p>
+            <a:r>
+              <a:rPr lang="en-US" sz="1600" dirty="0" smtClean="0"/>
+              <a:t>5.Send </a:t>
+            </a:r>
             <a:r>
               <a:rPr lang="en-US" sz="1600" dirty="0"/>
-              <a:t>Send Email</a:t>
+              <a:t>Email</a:t>
             </a:r>
             <a:r>
               <a:rPr lang="en-US" sz="1600" dirty="0" smtClean="0"/>
@@ -4159,6 +4224,46 @@
               <a:buNone/>
             </a:pPr>
             <a:endParaRPr lang="en-IN" dirty="0"/>
+          </a:p>
+        </p:txBody>
+      </p:sp>
+      <p:sp>
+        <p:nvSpPr>
+          <p:cNvPr id="4" name="Right Arrow 3"/>
+          <p:cNvSpPr/>
+          <p:nvPr/>
+        </p:nvSpPr>
+        <p:spPr>
+          <a:xfrm>
+            <a:off x="0" y="532666"/>
+            <a:ext cx="649481" cy="470566"/>
+          </a:xfrm>
+          <a:prstGeom prst="rightArrow">
+            <a:avLst/>
+          </a:prstGeom>
+        </p:spPr>
+        <p:style>
+          <a:lnRef idx="2">
+            <a:schemeClr val="accent1">
+              <a:shade val="50000"/>
+            </a:schemeClr>
+          </a:lnRef>
+          <a:fillRef idx="1">
+            <a:schemeClr val="accent1"/>
+          </a:fillRef>
+          <a:effectRef idx="0">
+            <a:schemeClr val="accent1"/>
+          </a:effectRef>
+          <a:fontRef idx="minor">
+            <a:schemeClr val="lt1"/>
+          </a:fontRef>
+        </p:style>
+        <p:txBody>
+          <a:bodyPr rtlCol="0" anchor="ctr"/>
+          <a:lstStyle/>
+          <a:p>
+            <a:pPr algn="ctr"/>
+            <a:endParaRPr lang="en-IN"/>
           </a:p>
         </p:txBody>
       </p:sp>
@@ -4258,30 +4363,50 @@
             </a:r>
           </a:p>
           <a:p>
+            <a:pPr marL="457200" indent="-457200">
+              <a:buFont typeface="+mj-lt"/>
+              <a:buAutoNum type="arabicPeriod"/>
+            </a:pPr>
             <a:r>
               <a:rPr lang="en-US" sz="2100" dirty="0"/>
               <a:t>Read complete sentence</a:t>
             </a:r>
           </a:p>
           <a:p>
+            <a:pPr marL="457200" indent="-457200">
+              <a:buFont typeface="+mj-lt"/>
+              <a:buAutoNum type="arabicPeriod"/>
+            </a:pPr>
             <a:r>
               <a:rPr lang="en-US" sz="2100" dirty="0"/>
               <a:t>Will see what to do — Read operation it is</a:t>
             </a:r>
           </a:p>
           <a:p>
+            <a:pPr marL="457200" indent="-457200">
+              <a:buFont typeface="+mj-lt"/>
+              <a:buAutoNum type="arabicPeriod"/>
+            </a:pPr>
             <a:r>
               <a:rPr lang="en-US" sz="2100" dirty="0"/>
               <a:t>Will navigate Log files</a:t>
             </a:r>
           </a:p>
           <a:p>
+            <a:pPr marL="457200" indent="-457200">
+              <a:buFont typeface="+mj-lt"/>
+              <a:buAutoNum type="arabicPeriod"/>
+            </a:pPr>
             <a:r>
               <a:rPr lang="en-US" sz="2100" dirty="0"/>
               <a:t>Search for Log file for date = Today’s Date -1 (yesterday)</a:t>
             </a:r>
           </a:p>
           <a:p>
+            <a:pPr marL="457200" indent="-457200">
+              <a:buFont typeface="+mj-lt"/>
+              <a:buAutoNum type="arabicPeriod"/>
+            </a:pPr>
             <a:r>
               <a:rPr lang="en-US" sz="2100" dirty="0"/>
               <a:t>Scan File and see date time present on logs and Capture </a:t>
@@ -4296,18 +4421,30 @@
             </a:r>
           </a:p>
           <a:p>
+            <a:pPr marL="457200" indent="-457200">
+              <a:buFont typeface="+mj-lt"/>
+              <a:buAutoNum type="arabicPeriod"/>
+            </a:pPr>
             <a:r>
               <a:rPr lang="en-US" sz="2100" dirty="0"/>
               <a:t>if Found then It will pick error Context</a:t>
             </a:r>
           </a:p>
           <a:p>
+            <a:pPr marL="457200" indent="-457200">
+              <a:buFont typeface="+mj-lt"/>
+              <a:buAutoNum type="arabicPeriod"/>
+            </a:pPr>
             <a:r>
               <a:rPr lang="en-US" sz="2100" dirty="0"/>
               <a:t>Make Call to Codex/ Claude Model to get detailed analysis and Root causes</a:t>
             </a:r>
           </a:p>
           <a:p>
+            <a:pPr marL="457200" indent="-457200">
+              <a:buFont typeface="+mj-lt"/>
+              <a:buAutoNum type="arabicPeriod"/>
+            </a:pPr>
             <a:r>
               <a:rPr lang="en-US" sz="2100" dirty="0"/>
               <a:t>Will Drop Email to Admin.</a:t>
@@ -4315,6 +4452,46 @@
           </a:p>
           <a:p>
             <a:endParaRPr lang="en-IN" dirty="0"/>
+          </a:p>
+        </p:txBody>
+      </p:sp>
+      <p:sp>
+        <p:nvSpPr>
+          <p:cNvPr id="4" name="Right Arrow 3"/>
+          <p:cNvSpPr/>
+          <p:nvPr/>
+        </p:nvSpPr>
+        <p:spPr>
+          <a:xfrm>
+            <a:off x="222190" y="1204958"/>
+            <a:ext cx="649481" cy="470566"/>
+          </a:xfrm>
+          <a:prstGeom prst="rightArrow">
+            <a:avLst/>
+          </a:prstGeom>
+        </p:spPr>
+        <p:style>
+          <a:lnRef idx="2">
+            <a:schemeClr val="accent1">
+              <a:shade val="50000"/>
+            </a:schemeClr>
+          </a:lnRef>
+          <a:fillRef idx="1">
+            <a:schemeClr val="accent1"/>
+          </a:fillRef>
+          <a:effectRef idx="0">
+            <a:schemeClr val="accent1"/>
+          </a:effectRef>
+          <a:fontRef idx="minor">
+            <a:schemeClr val="lt1"/>
+          </a:fontRef>
+        </p:style>
+        <p:txBody>
+          <a:bodyPr rtlCol="0" anchor="ctr"/>
+          <a:lstStyle/>
+          <a:p>
+            <a:pPr algn="ctr"/>
+            <a:endParaRPr lang="en-IN"/>
           </a:p>
         </p:txBody>
       </p:sp>
@@ -4492,6 +4669,46 @@
           </a:p>
         </p:txBody>
       </p:sp>
+      <p:sp>
+        <p:nvSpPr>
+          <p:cNvPr id="4" name="Right Arrow 3"/>
+          <p:cNvSpPr/>
+          <p:nvPr/>
+        </p:nvSpPr>
+        <p:spPr>
+          <a:xfrm>
+            <a:off x="222190" y="1204958"/>
+            <a:ext cx="649481" cy="470566"/>
+          </a:xfrm>
+          <a:prstGeom prst="rightArrow">
+            <a:avLst/>
+          </a:prstGeom>
+        </p:spPr>
+        <p:style>
+          <a:lnRef idx="2">
+            <a:schemeClr val="accent1">
+              <a:shade val="50000"/>
+            </a:schemeClr>
+          </a:lnRef>
+          <a:fillRef idx="1">
+            <a:schemeClr val="accent1"/>
+          </a:fillRef>
+          <a:effectRef idx="0">
+            <a:schemeClr val="accent1"/>
+          </a:effectRef>
+          <a:fontRef idx="minor">
+            <a:schemeClr val="lt1"/>
+          </a:fontRef>
+        </p:style>
+        <p:txBody>
+          <a:bodyPr rtlCol="0" anchor="ctr"/>
+          <a:lstStyle/>
+          <a:p>
+            <a:pPr algn="ctr"/>
+            <a:endParaRPr lang="en-IN"/>
+          </a:p>
+        </p:txBody>
+      </p:sp>
     </p:spTree>
     <p:extLst>
       <p:ext uri="{BB962C8B-B14F-4D97-AF65-F5344CB8AC3E}">
@@ -4573,6 +4790,46 @@
           </a:prstGeom>
         </p:spPr>
       </p:pic>
+      <p:sp>
+        <p:nvSpPr>
+          <p:cNvPr id="3" name="Right Arrow 2"/>
+          <p:cNvSpPr/>
+          <p:nvPr/>
+        </p:nvSpPr>
+        <p:spPr>
+          <a:xfrm>
+            <a:off x="222190" y="1204958"/>
+            <a:ext cx="649481" cy="470566"/>
+          </a:xfrm>
+          <a:prstGeom prst="rightArrow">
+            <a:avLst/>
+          </a:prstGeom>
+        </p:spPr>
+        <p:style>
+          <a:lnRef idx="2">
+            <a:schemeClr val="accent1">
+              <a:shade val="50000"/>
+            </a:schemeClr>
+          </a:lnRef>
+          <a:fillRef idx="1">
+            <a:schemeClr val="accent1"/>
+          </a:fillRef>
+          <a:effectRef idx="0">
+            <a:schemeClr val="accent1"/>
+          </a:effectRef>
+          <a:fontRef idx="minor">
+            <a:schemeClr val="lt1"/>
+          </a:fontRef>
+        </p:style>
+        <p:txBody>
+          <a:bodyPr rtlCol="0" anchor="ctr"/>
+          <a:lstStyle/>
+          <a:p>
+            <a:pPr algn="ctr"/>
+            <a:endParaRPr lang="en-IN"/>
+          </a:p>
+        </p:txBody>
+      </p:sp>
     </p:spTree>
     <p:extLst>
       <p:ext uri="{BB962C8B-B14F-4D97-AF65-F5344CB8AC3E}">
@@ -4663,6 +4920,46 @@
           </a:prstGeom>
         </p:spPr>
       </p:pic>
+      <p:sp>
+        <p:nvSpPr>
+          <p:cNvPr id="4" name="Right Arrow 3"/>
+          <p:cNvSpPr/>
+          <p:nvPr/>
+        </p:nvSpPr>
+        <p:spPr>
+          <a:xfrm>
+            <a:off x="222190" y="1204958"/>
+            <a:ext cx="649481" cy="470566"/>
+          </a:xfrm>
+          <a:prstGeom prst="rightArrow">
+            <a:avLst/>
+          </a:prstGeom>
+        </p:spPr>
+        <p:style>
+          <a:lnRef idx="2">
+            <a:schemeClr val="accent1">
+              <a:shade val="50000"/>
+            </a:schemeClr>
+          </a:lnRef>
+          <a:fillRef idx="1">
+            <a:schemeClr val="accent1"/>
+          </a:fillRef>
+          <a:effectRef idx="0">
+            <a:schemeClr val="accent1"/>
+          </a:effectRef>
+          <a:fontRef idx="minor">
+            <a:schemeClr val="lt1"/>
+          </a:fontRef>
+        </p:style>
+        <p:txBody>
+          <a:bodyPr rtlCol="0" anchor="ctr"/>
+          <a:lstStyle/>
+          <a:p>
+            <a:pPr algn="ctr"/>
+            <a:endParaRPr lang="en-IN"/>
+          </a:p>
+        </p:txBody>
+      </p:sp>
     </p:spTree>
     <p:extLst>
       <p:ext uri="{BB962C8B-B14F-4D97-AF65-F5344CB8AC3E}">
@@ -4935,6 +5232,46 @@
           </a:p>
           <a:p>
             <a:endParaRPr lang="en-IN" dirty="0"/>
+          </a:p>
+        </p:txBody>
+      </p:sp>
+      <p:sp>
+        <p:nvSpPr>
+          <p:cNvPr id="4" name="Right Arrow 3"/>
+          <p:cNvSpPr/>
+          <p:nvPr/>
+        </p:nvSpPr>
+        <p:spPr>
+          <a:xfrm>
+            <a:off x="222190" y="1204958"/>
+            <a:ext cx="649481" cy="470566"/>
+          </a:xfrm>
+          <a:prstGeom prst="rightArrow">
+            <a:avLst/>
+          </a:prstGeom>
+        </p:spPr>
+        <p:style>
+          <a:lnRef idx="2">
+            <a:schemeClr val="accent1">
+              <a:shade val="50000"/>
+            </a:schemeClr>
+          </a:lnRef>
+          <a:fillRef idx="1">
+            <a:schemeClr val="accent1"/>
+          </a:fillRef>
+          <a:effectRef idx="0">
+            <a:schemeClr val="accent1"/>
+          </a:effectRef>
+          <a:fontRef idx="minor">
+            <a:schemeClr val="lt1"/>
+          </a:fontRef>
+        </p:style>
+        <p:txBody>
+          <a:bodyPr rtlCol="0" anchor="ctr"/>
+          <a:lstStyle/>
+          <a:p>
+            <a:pPr algn="ctr"/>
+            <a:endParaRPr lang="en-IN"/>
           </a:p>
         </p:txBody>
       </p:sp>
@@ -5195,16 +5532,46 @@
               </a:rPr>
               <a:t>Most requests are of moderate complexity. </a:t>
             </a:r>
-            <a:endParaRPr kumimoji="0" lang="en-US" sz="1800" b="0" i="0" u="none" strike="noStrike" cap="none" normalizeH="0" baseline="0" dirty="0" smtClean="0">
-              <a:ln>
-                <a:noFill/>
-              </a:ln>
-              <a:solidFill>
-                <a:schemeClr val="tx1"/>
-              </a:solidFill>
-              <a:effectLst/>
-              <a:latin typeface="Arial" panose="020B0604020202020204" pitchFamily="34" charset="0"/>
-            </a:endParaRPr>
+          </a:p>
+        </p:txBody>
+      </p:sp>
+      <p:sp>
+        <p:nvSpPr>
+          <p:cNvPr id="5" name="Right Arrow 4"/>
+          <p:cNvSpPr/>
+          <p:nvPr/>
+        </p:nvSpPr>
+        <p:spPr>
+          <a:xfrm>
+            <a:off x="222190" y="1204958"/>
+            <a:ext cx="649481" cy="470566"/>
+          </a:xfrm>
+          <a:prstGeom prst="rightArrow">
+            <a:avLst/>
+          </a:prstGeom>
+        </p:spPr>
+        <p:style>
+          <a:lnRef idx="2">
+            <a:schemeClr val="accent1">
+              <a:shade val="50000"/>
+            </a:schemeClr>
+          </a:lnRef>
+          <a:fillRef idx="1">
+            <a:schemeClr val="accent1"/>
+          </a:fillRef>
+          <a:effectRef idx="0">
+            <a:schemeClr val="accent1"/>
+          </a:effectRef>
+          <a:fontRef idx="minor">
+            <a:schemeClr val="lt1"/>
+          </a:fontRef>
+        </p:style>
+        <p:txBody>
+          <a:bodyPr rtlCol="0" anchor="ctr"/>
+          <a:lstStyle/>
+          <a:p>
+            <a:pPr algn="ctr"/>
+            <a:endParaRPr lang="en-IN"/>
           </a:p>
         </p:txBody>
       </p:sp>
@@ -5341,6 +5708,46 @@
           </a:p>
         </p:txBody>
       </p:sp>
+      <p:sp>
+        <p:nvSpPr>
+          <p:cNvPr id="4" name="Right Arrow 3"/>
+          <p:cNvSpPr/>
+          <p:nvPr/>
+        </p:nvSpPr>
+        <p:spPr>
+          <a:xfrm>
+            <a:off x="318259" y="1011981"/>
+            <a:ext cx="649481" cy="470566"/>
+          </a:xfrm>
+          <a:prstGeom prst="rightArrow">
+            <a:avLst/>
+          </a:prstGeom>
+        </p:spPr>
+        <p:style>
+          <a:lnRef idx="2">
+            <a:schemeClr val="accent1">
+              <a:shade val="50000"/>
+            </a:schemeClr>
+          </a:lnRef>
+          <a:fillRef idx="1">
+            <a:schemeClr val="accent1"/>
+          </a:fillRef>
+          <a:effectRef idx="0">
+            <a:schemeClr val="accent1"/>
+          </a:effectRef>
+          <a:fontRef idx="minor">
+            <a:schemeClr val="lt1"/>
+          </a:fontRef>
+        </p:style>
+        <p:txBody>
+          <a:bodyPr rtlCol="0" anchor="ctr"/>
+          <a:lstStyle/>
+          <a:p>
+            <a:pPr algn="ctr"/>
+            <a:endParaRPr lang="en-IN"/>
+          </a:p>
+        </p:txBody>
+      </p:sp>
     </p:spTree>
     <p:extLst>
       <p:ext uri="{BB962C8B-B14F-4D97-AF65-F5344CB8AC3E}">
@@ -5447,6 +5854,46 @@
           </a:p>
           <a:p>
             <a:endParaRPr lang="en-IN" dirty="0"/>
+          </a:p>
+        </p:txBody>
+      </p:sp>
+      <p:sp>
+        <p:nvSpPr>
+          <p:cNvPr id="4" name="Right Arrow 3"/>
+          <p:cNvSpPr/>
+          <p:nvPr/>
+        </p:nvSpPr>
+        <p:spPr>
+          <a:xfrm>
+            <a:off x="222190" y="1204958"/>
+            <a:ext cx="649481" cy="470566"/>
+          </a:xfrm>
+          <a:prstGeom prst="rightArrow">
+            <a:avLst/>
+          </a:prstGeom>
+        </p:spPr>
+        <p:style>
+          <a:lnRef idx="2">
+            <a:schemeClr val="accent1">
+              <a:shade val="50000"/>
+            </a:schemeClr>
+          </a:lnRef>
+          <a:fillRef idx="1">
+            <a:schemeClr val="accent1"/>
+          </a:fillRef>
+          <a:effectRef idx="0">
+            <a:schemeClr val="accent1"/>
+          </a:effectRef>
+          <a:fontRef idx="minor">
+            <a:schemeClr val="lt1"/>
+          </a:fontRef>
+        </p:style>
+        <p:txBody>
+          <a:bodyPr rtlCol="0" anchor="ctr"/>
+          <a:lstStyle/>
+          <a:p>
+            <a:pPr algn="ctr"/>
+            <a:endParaRPr lang="en-IN"/>
           </a:p>
         </p:txBody>
       </p:sp>
@@ -5589,6 +6036,46 @@
           </a:p>
         </p:txBody>
       </p:sp>
+      <p:sp>
+        <p:nvSpPr>
+          <p:cNvPr id="4" name="Right Arrow 3"/>
+          <p:cNvSpPr/>
+          <p:nvPr/>
+        </p:nvSpPr>
+        <p:spPr>
+          <a:xfrm>
+            <a:off x="222190" y="1204958"/>
+            <a:ext cx="649481" cy="470566"/>
+          </a:xfrm>
+          <a:prstGeom prst="rightArrow">
+            <a:avLst/>
+          </a:prstGeom>
+        </p:spPr>
+        <p:style>
+          <a:lnRef idx="2">
+            <a:schemeClr val="accent1">
+              <a:shade val="50000"/>
+            </a:schemeClr>
+          </a:lnRef>
+          <a:fillRef idx="1">
+            <a:schemeClr val="accent1"/>
+          </a:fillRef>
+          <a:effectRef idx="0">
+            <a:schemeClr val="accent1"/>
+          </a:effectRef>
+          <a:fontRef idx="minor">
+            <a:schemeClr val="lt1"/>
+          </a:fontRef>
+        </p:style>
+        <p:txBody>
+          <a:bodyPr rtlCol="0" anchor="ctr"/>
+          <a:lstStyle/>
+          <a:p>
+            <a:pPr algn="ctr"/>
+            <a:endParaRPr lang="en-IN"/>
+          </a:p>
+        </p:txBody>
+      </p:sp>
     </p:spTree>
     <p:extLst>
       <p:ext uri="{BB962C8B-B14F-4D97-AF65-F5344CB8AC3E}">
@@ -5677,7 +6164,15 @@
             </a:pPr>
             <a:r>
               <a:rPr lang="en-US" sz="1600" i="1" dirty="0"/>
-              <a:t>“Can you give email me my order details and please share last 5 month orders</a:t>
+              <a:t>“Can you </a:t>
+            </a:r>
+            <a:r>
+              <a:rPr lang="en-US" sz="1600" i="1" dirty="0" smtClean="0"/>
+              <a:t>write and drop email </a:t>
+            </a:r>
+            <a:r>
+              <a:rPr lang="en-US" sz="1600" i="1" dirty="0"/>
+              <a:t>me my order details and please share last 5 month orders</a:t>
             </a:r>
             <a:r>
               <a:rPr lang="en-US" sz="1600" i="1" dirty="0" smtClean="0"/>
@@ -5747,6 +6242,46 @@
               <a:buAutoNum type="arabicPeriod"/>
             </a:pPr>
             <a:endParaRPr lang="en-IN" sz="1600" dirty="0"/>
+          </a:p>
+        </p:txBody>
+      </p:sp>
+      <p:sp>
+        <p:nvSpPr>
+          <p:cNvPr id="4" name="Right Arrow 3"/>
+          <p:cNvSpPr/>
+          <p:nvPr/>
+        </p:nvSpPr>
+        <p:spPr>
+          <a:xfrm>
+            <a:off x="222190" y="1204958"/>
+            <a:ext cx="649481" cy="470566"/>
+          </a:xfrm>
+          <a:prstGeom prst="rightArrow">
+            <a:avLst/>
+          </a:prstGeom>
+        </p:spPr>
+        <p:style>
+          <a:lnRef idx="2">
+            <a:schemeClr val="accent1">
+              <a:shade val="50000"/>
+            </a:schemeClr>
+          </a:lnRef>
+          <a:fillRef idx="1">
+            <a:schemeClr val="accent1"/>
+          </a:fillRef>
+          <a:effectRef idx="0">
+            <a:schemeClr val="accent1"/>
+          </a:effectRef>
+          <a:fontRef idx="minor">
+            <a:schemeClr val="lt1"/>
+          </a:fontRef>
+        </p:style>
+        <p:txBody>
+          <a:bodyPr rtlCol="0" anchor="ctr"/>
+          <a:lstStyle/>
+          <a:p>
+            <a:pPr algn="ctr"/>
+            <a:endParaRPr lang="en-IN"/>
           </a:p>
         </p:txBody>
       </p:sp>

</xml_diff>

<commit_message>
Session 4 Aug 9
</commit_message>
<xml_diff>
--- a/session3/Choosing Between Models.pptx
+++ b/session3/Choosing Between Models.pptx
@@ -4119,7 +4119,15 @@
             </a:r>
             <a:r>
               <a:rPr lang="en-US" sz="1600" dirty="0"/>
-              <a:t>“Can you give email me my order details and please share last 5 month orders</a:t>
+              <a:t>“Can you </a:t>
+            </a:r>
+            <a:r>
+              <a:rPr lang="en-US" sz="1600" dirty="0" smtClean="0"/>
+              <a:t>drop email </a:t>
+            </a:r>
+            <a:r>
+              <a:rPr lang="en-US" sz="1600" dirty="0"/>
+              <a:t>me my order details and please share last 5 month orders</a:t>
             </a:r>
             <a:r>
               <a:rPr lang="en-US" sz="1600" dirty="0" smtClean="0"/>
@@ -4463,7 +4471,7 @@
         </p:nvSpPr>
         <p:spPr>
           <a:xfrm>
-            <a:off x="222190" y="1204958"/>
+            <a:off x="581113" y="5110386"/>
             <a:ext cx="649481" cy="470566"/>
           </a:xfrm>
           <a:prstGeom prst="rightArrow">
@@ -4677,7 +4685,7 @@
         </p:nvSpPr>
         <p:spPr>
           <a:xfrm>
-            <a:off x="222190" y="1204958"/>
+            <a:off x="447799" y="1085698"/>
             <a:ext cx="649481" cy="470566"/>
           </a:xfrm>
           <a:prstGeom prst="rightArrow">
@@ -4798,7 +4806,7 @@
         </p:nvSpPr>
         <p:spPr>
           <a:xfrm>
-            <a:off x="222190" y="1204958"/>
+            <a:off x="179461" y="1128046"/>
             <a:ext cx="649481" cy="470566"/>
           </a:xfrm>
           <a:prstGeom prst="rightArrow">
@@ -4928,7 +4936,7 @@
         </p:nvSpPr>
         <p:spPr>
           <a:xfrm>
-            <a:off x="222190" y="1204958"/>
+            <a:off x="7828832" y="4603478"/>
             <a:ext cx="649481" cy="470566"/>
           </a:xfrm>
           <a:prstGeom prst="rightArrow">
@@ -5014,11 +5022,15 @@
           <a:p>
             <a:r>
               <a:rPr lang="en-IN" b="1" dirty="0" smtClean="0"/>
-              <a:t>Flagship</a:t>
+              <a:t>Flagship/Reasoning Models</a:t>
             </a:r>
             <a:r>
               <a:rPr lang="en-IN" dirty="0" smtClean="0"/>
-              <a:t> model</a:t>
+              <a:t> </a:t>
+            </a:r>
+            <a:r>
+              <a:rPr lang="en-IN" dirty="0" smtClean="0"/>
+              <a:t>model</a:t>
             </a:r>
             <a:endParaRPr lang="en-IN" dirty="0"/>
           </a:p>
@@ -5089,6 +5101,29 @@
               </a:rPr>
               <a:t>Accuracy matters more than cost. </a:t>
             </a:r>
+            <a:r>
+              <a:rPr kumimoji="0" lang="en-US" b="0" i="0" u="none" strike="noStrike" cap="none" normalizeH="0" baseline="0" dirty="0" smtClean="0">
+                <a:ln>
+                  <a:noFill/>
+                </a:ln>
+                <a:solidFill>
+                  <a:schemeClr val="tx1"/>
+                </a:solidFill>
+                <a:effectLst/>
+                <a:latin typeface="Arial" panose="020B0604020202020204" pitchFamily="34" charset="0"/>
+              </a:rPr>
+              <a:t>(Tax sheet)</a:t>
+            </a:r>
+            <a:endParaRPr kumimoji="0" lang="en-US" b="0" i="0" u="none" strike="noStrike" cap="none" normalizeH="0" baseline="0" dirty="0" smtClean="0">
+              <a:ln>
+                <a:noFill/>
+              </a:ln>
+              <a:solidFill>
+                <a:schemeClr val="tx1"/>
+              </a:solidFill>
+              <a:effectLst/>
+              <a:latin typeface="Arial" panose="020B0604020202020204" pitchFamily="34" charset="0"/>
+            </a:endParaRPr>
           </a:p>
           <a:p>
             <a:pPr marL="0" lvl="0" indent="0" eaLnBrk="0" fontAlgn="base" hangingPunct="0">
@@ -5243,7 +5278,7 @@
         </p:nvSpPr>
         <p:spPr>
           <a:xfrm>
-            <a:off x="222190" y="1204958"/>
+            <a:off x="772539" y="3865095"/>
             <a:ext cx="649481" cy="470566"/>
           </a:xfrm>
           <a:prstGeom prst="rightArrow">
@@ -5543,7 +5578,7 @@
         </p:nvSpPr>
         <p:spPr>
           <a:xfrm>
-            <a:off x="222190" y="1204958"/>
+            <a:off x="523999" y="2295269"/>
             <a:ext cx="649481" cy="470566"/>
           </a:xfrm>
           <a:prstGeom prst="rightArrow">
@@ -5585,6 +5620,13 @@
   <p:clrMapOvr>
     <a:masterClrMapping/>
   </p:clrMapOvr>
+  <p:timing>
+    <p:tnLst>
+      <p:par>
+        <p:cTn id="1" dur="indefinite" restart="never" nodeType="tmRoot"/>
+      </p:par>
+    </p:tnLst>
+  </p:timing>
 </p:sld>
 </file>
 
@@ -5640,7 +5682,7 @@
         </p:nvSpPr>
         <p:spPr>
           <a:xfrm>
-            <a:off x="838200" y="1690688"/>
+            <a:off x="1313688" y="1737360"/>
             <a:ext cx="6096000" cy="923330"/>
           </a:xfrm>
           <a:prstGeom prst="rect">
@@ -5716,7 +5758,7 @@
         </p:nvSpPr>
         <p:spPr>
           <a:xfrm>
-            <a:off x="318259" y="1011981"/>
+            <a:off x="447799" y="1096571"/>
             <a:ext cx="649481" cy="470566"/>
           </a:xfrm>
           <a:prstGeom prst="rightArrow">
@@ -5865,7 +5907,7 @@
         </p:nvSpPr>
         <p:spPr>
           <a:xfrm>
-            <a:off x="222190" y="1204958"/>
+            <a:off x="447799" y="3622131"/>
             <a:ext cx="649481" cy="470566"/>
           </a:xfrm>
           <a:prstGeom prst="rightArrow">
@@ -6044,7 +6086,7 @@
         </p:nvSpPr>
         <p:spPr>
           <a:xfrm>
-            <a:off x="222190" y="1204958"/>
+            <a:off x="551374" y="4929614"/>
             <a:ext cx="649481" cy="470566"/>
           </a:xfrm>
           <a:prstGeom prst="rightArrow">
@@ -6253,7 +6295,7 @@
         </p:nvSpPr>
         <p:spPr>
           <a:xfrm>
-            <a:off x="222190" y="1204958"/>
+            <a:off x="306010" y="2180318"/>
             <a:ext cx="649481" cy="470566"/>
           </a:xfrm>
           <a:prstGeom prst="rightArrow">

</xml_diff>